<commit_message>
Decks: align slide text with the verified CLI behavior
eval snippets use the return form, the reskin deck no longer promises
VFX recoloring via exposed parameters (VFX_CellCrash has none) and names
the separate HUD icon set, and the Ex09 line reflects the one-time build
stop on drifted Build Settings.

Co-Authored-By: Claude Fable 5.1 <noreply@anthropic.com>
</commit_message>
<xml_diff>
--- a/single_day/slides/03_foreign_code_demo.pptx
+++ b/single_day/slides/03_foreign_code_demo.pptx
@@ -3473,7 +3473,7 @@
                 <a:ea typeface="Courier New" pitchFamily="34" charset="-122"/>
                 <a:cs typeface="Courier New" pitchFamily="34" charset="-120"/>
               </a:rPr>
-              <a:t>  'Match3.LevelData.Instance</a:t>
+              <a:t>  'return Match3.LevelData</a:t>
             </a:r>
             <a:endParaRPr lang="en-US" sz="1150" dirty="0"/>
           </a:p>
@@ -3493,7 +3493,7 @@
                 <a:ea typeface="Courier New" pitchFamily="34" charset="-122"/>
                 <a:cs typeface="Courier New" pitchFamily="34" charset="-120"/>
               </a:rPr>
-              <a:t>   .RemainingMove' → 20</a:t>
+              <a:t>   .Instance.RemainingMove;' → 20</a:t>
             </a:r>
             <a:endParaRPr lang="en-US" sz="1150" dirty="0"/>
           </a:p>

</xml_diff>